<commit_message>
improve transparency of doc figures
</commit_message>
<xml_diff>
--- a/documentation/figures/parentUID_transformations.pptx
+++ b/documentation/figures/parentUID_transformations.pptx
@@ -261,7 +261,7 @@
           <a:p>
             <a:fld id="{4BA96097-E4F7-4049-AA93-EF26FCCEF44B}" type="datetimeFigureOut">
               <a:rPr lang="en-US" smtClean="0"/>
-              <a:t>11/1/2021</a:t>
+              <a:t>8/24/2026</a:t>
             </a:fld>
             <a:endParaRPr lang="en-US"/>
           </a:p>
@@ -461,7 +461,7 @@
           <a:p>
             <a:fld id="{4BA96097-E4F7-4049-AA93-EF26FCCEF44B}" type="datetimeFigureOut">
               <a:rPr lang="en-US" smtClean="0"/>
-              <a:t>11/1/2021</a:t>
+              <a:t>8/24/2026</a:t>
             </a:fld>
             <a:endParaRPr lang="en-US"/>
           </a:p>
@@ -671,7 +671,7 @@
           <a:p>
             <a:fld id="{4BA96097-E4F7-4049-AA93-EF26FCCEF44B}" type="datetimeFigureOut">
               <a:rPr lang="en-US" smtClean="0"/>
-              <a:t>11/1/2021</a:t>
+              <a:t>8/24/2026</a:t>
             </a:fld>
             <a:endParaRPr lang="en-US"/>
           </a:p>
@@ -871,7 +871,7 @@
           <a:p>
             <a:fld id="{4BA96097-E4F7-4049-AA93-EF26FCCEF44B}" type="datetimeFigureOut">
               <a:rPr lang="en-US" smtClean="0"/>
-              <a:t>11/1/2021</a:t>
+              <a:t>8/24/2026</a:t>
             </a:fld>
             <a:endParaRPr lang="en-US"/>
           </a:p>
@@ -1147,7 +1147,7 @@
           <a:p>
             <a:fld id="{4BA96097-E4F7-4049-AA93-EF26FCCEF44B}" type="datetimeFigureOut">
               <a:rPr lang="en-US" smtClean="0"/>
-              <a:t>11/1/2021</a:t>
+              <a:t>8/24/2026</a:t>
             </a:fld>
             <a:endParaRPr lang="en-US"/>
           </a:p>
@@ -1415,7 +1415,7 @@
           <a:p>
             <a:fld id="{4BA96097-E4F7-4049-AA93-EF26FCCEF44B}" type="datetimeFigureOut">
               <a:rPr lang="en-US" smtClean="0"/>
-              <a:t>11/1/2021</a:t>
+              <a:t>8/24/2026</a:t>
             </a:fld>
             <a:endParaRPr lang="en-US"/>
           </a:p>
@@ -1830,7 +1830,7 @@
           <a:p>
             <a:fld id="{4BA96097-E4F7-4049-AA93-EF26FCCEF44B}" type="datetimeFigureOut">
               <a:rPr lang="en-US" smtClean="0"/>
-              <a:t>11/1/2021</a:t>
+              <a:t>8/24/2026</a:t>
             </a:fld>
             <a:endParaRPr lang="en-US"/>
           </a:p>
@@ -1972,7 +1972,7 @@
           <a:p>
             <a:fld id="{4BA96097-E4F7-4049-AA93-EF26FCCEF44B}" type="datetimeFigureOut">
               <a:rPr lang="en-US" smtClean="0"/>
-              <a:t>11/1/2021</a:t>
+              <a:t>8/24/2026</a:t>
             </a:fld>
             <a:endParaRPr lang="en-US"/>
           </a:p>
@@ -2085,7 +2085,7 @@
           <a:p>
             <a:fld id="{4BA96097-E4F7-4049-AA93-EF26FCCEF44B}" type="datetimeFigureOut">
               <a:rPr lang="en-US" smtClean="0"/>
-              <a:t>11/1/2021</a:t>
+              <a:t>8/24/2026</a:t>
             </a:fld>
             <a:endParaRPr lang="en-US"/>
           </a:p>
@@ -2398,7 +2398,7 @@
           <a:p>
             <a:fld id="{4BA96097-E4F7-4049-AA93-EF26FCCEF44B}" type="datetimeFigureOut">
               <a:rPr lang="en-US" smtClean="0"/>
-              <a:t>11/1/2021</a:t>
+              <a:t>8/24/2026</a:t>
             </a:fld>
             <a:endParaRPr lang="en-US"/>
           </a:p>
@@ -2687,7 +2687,7 @@
           <a:p>
             <a:fld id="{4BA96097-E4F7-4049-AA93-EF26FCCEF44B}" type="datetimeFigureOut">
               <a:rPr lang="en-US" smtClean="0"/>
-              <a:t>11/1/2021</a:t>
+              <a:t>8/24/2026</a:t>
             </a:fld>
             <a:endParaRPr lang="en-US"/>
           </a:p>
@@ -2930,7 +2930,7 @@
           <a:p>
             <a:fld id="{4BA96097-E4F7-4049-AA93-EF26FCCEF44B}" type="datetimeFigureOut">
               <a:rPr lang="en-US" smtClean="0"/>
-              <a:t>11/1/2021</a:t>
+              <a:t>8/24/2026</a:t>
             </a:fld>
             <a:endParaRPr lang="en-US"/>
           </a:p>
@@ -3363,6 +3363,16 @@
         </p:nvPicPr>
         <p:blipFill rotWithShape="1">
           <a:blip r:embed="rId2">
+            <a:clrChange>
+              <a:clrFrom>
+                <a:srgbClr val="FFFFFF"/>
+              </a:clrFrom>
+              <a:clrTo>
+                <a:srgbClr val="FFFFFF">
+                  <a:alpha val="0"/>
+                </a:srgbClr>
+              </a:clrTo>
+            </a:clrChange>
             <a:extLst>
               <a:ext uri="{28A0092B-C50C-407E-A947-70E740481C1C}">
                 <a14:useLocalDpi xmlns:a14="http://schemas.microsoft.com/office/drawing/2010/main" val="0"/>

</xml_diff>